<commit_message>
Day 2 morning nosoln accessible: convert 12 OLE equations, chart alt text, fix 47 PUA chars
Co-Authored-By: Claude Opus 4.8 <noreply@anthropic.com>
</commit_message>
<xml_diff>
--- a/Day2_GLM/FW536_Day2_Morning_ContinuousDistributions_nosoln_accessible.pptx
+++ b/Day2_GLM/FW536_Day2_Morning_ContinuousDistributions_nosoln_accessible.pptx
@@ -7218,10 +7218,8 @@
               <a:t> is normally distributed with mean </a:t>
             </a:r>
             <a:r>
-              <a:rPr lang="en-US" altLang="en-US" dirty="0">
-                <a:sym typeface="Symbol" charset="2"/>
-              </a:rPr>
-              <a:t> and standard deviation </a:t>
+              <a:rPr lang="en-US" altLang="en-US" dirty="0"/>
+              <a:t>μ and standard deviation σ</a:t>
             </a:r>
           </a:p>
           <a:p>
@@ -7337,206 +7335,104 @@
           </a:p>
         </p:txBody>
       </p:sp>
-      <p:graphicFrame>
-        <p:nvGraphicFramePr>
-          <p:cNvPr id="238595" name="Object 4"/>
-          <p:cNvGraphicFramePr>
-            <a:graphicFrameLocks noGrp="1" noChangeAspect="1"/>
-          </p:cNvGraphicFramePr>
-          <p:nvPr>
-            <p:ph sz="quarter" idx="2"/>
-            <p:extLst>
-              <p:ext uri="{D42A27DB-BD31-4B8C-83A1-F6EECF244321}">
-                <p14:modId xmlns:p14="http://schemas.microsoft.com/office/powerpoint/2010/main" val="1270787266"/>
-              </p:ext>
-            </p:extLst>
-          </p:nvPr>
-        </p:nvGraphicFramePr>
-        <p:xfrm>
-          <a:off x="4752976" y="2058757"/>
-          <a:ext cx="1598613" cy="411162"/>
-        </p:xfrm>
-        <a:graphic>
-          <a:graphicData uri="http://schemas.openxmlformats.org/presentationml/2006/ole">
-            <mc:AlternateContent xmlns:mc="http://schemas.openxmlformats.org/markup-compatibility/2006">
-              <mc:Choice xmlns:v="urn:schemas-microsoft-com:vml" Requires="v">
-                <p:oleObj name="Equation" r:id="rId3" imgW="889000" imgH="228600" progId="Equation.DSMT4">
-                  <p:embed/>
-                </p:oleObj>
-              </mc:Choice>
-              <mc:Fallback>
-                <p:oleObj name="Equation" r:id="rId3" imgW="889000" imgH="228600" progId="Equation.DSMT4">
-                  <p:embed/>
-                  <p:pic>
-                    <p:nvPicPr>
-                      <p:cNvPr id="0" name=""/>
-                      <p:cNvPicPr>
-                        <a:picLocks noChangeAspect="1" noChangeArrowheads="1"/>
-                      </p:cNvPicPr>
-                      <p:nvPr/>
-                    </p:nvPicPr>
-                    <p:blipFill>
-                      <a:blip r:embed="rId4">
-                        <a:extLst>
-                          <a:ext uri="{28A0092B-C50C-407E-A947-70E740481C1C}">
-                            <a14:useLocalDpi xmlns:a14="http://schemas.microsoft.com/office/drawing/2010/main" val="0"/>
-                          </a:ext>
-                        </a:extLst>
-                      </a:blip>
-                      <a:srcRect/>
-                      <a:stretch>
-                        <a:fillRect/>
-                      </a:stretch>
-                    </p:blipFill>
-                    <p:spPr bwMode="auto">
-                      <a:xfrm>
-                        <a:off x="4752976" y="2058757"/>
-                        <a:ext cx="1598613" cy="411162"/>
-                      </a:xfrm>
-                      <a:prstGeom prst="rect">
-                        <a:avLst/>
-                      </a:prstGeom>
-                      <a:noFill/>
-                      <a:ln>
-                        <a:noFill/>
-                      </a:ln>
-                      <a:effectLst/>
-                      <a:extLst>
-                        <a:ext uri="{909E8E84-426E-40DD-AFC4-6F175D3DCCD1}">
-                          <a14:hiddenFill xmlns:a14="http://schemas.microsoft.com/office/drawing/2010/main">
-                            <a:solidFill>
-                              <a:srgbClr val="FFFFFF"/>
-                            </a:solidFill>
-                          </a14:hiddenFill>
-                        </a:ext>
-                        <a:ext uri="{91240B29-F687-4F45-9708-019B960494DF}">
-                          <a14:hiddenLine xmlns:a14="http://schemas.microsoft.com/office/drawing/2010/main" w="9525">
-                            <a:solidFill>
-                              <a:srgbClr val="000000"/>
-                            </a:solidFill>
-                            <a:miter lim="800000"/>
-                            <a:headEnd/>
-                            <a:tailEnd/>
-                          </a14:hiddenLine>
-                        </a:ext>
-                        <a:ext uri="{AF507438-7753-43E0-B8FC-AC1667EBCBE1}">
-                          <a14:hiddenEffects xmlns:a14="http://schemas.microsoft.com/office/drawing/2010/main">
-                            <a:effectLst>
-                              <a:outerShdw dist="35921" dir="2700000" algn="ctr" rotWithShape="0">
-                                <a:srgbClr val="808080"/>
-                              </a:outerShdw>
-                            </a:effectLst>
-                          </a14:hiddenEffects>
-                        </a:ext>
-                      </a:extLst>
-                    </p:spPr>
-                  </p:pic>
-                </p:oleObj>
-              </mc:Fallback>
-            </mc:AlternateContent>
-          </a:graphicData>
-        </a:graphic>
-      </p:graphicFrame>
-      <p:graphicFrame>
-        <p:nvGraphicFramePr>
-          <p:cNvPr id="238596" name="Object 6"/>
-          <p:cNvGraphicFramePr>
-            <a:graphicFrameLocks noGrp="1" noChangeAspect="1"/>
-          </p:cNvGraphicFramePr>
-          <p:nvPr>
-            <p:ph sz="quarter" idx="3"/>
-            <p:extLst>
-              <p:ext uri="{D42A27DB-BD31-4B8C-83A1-F6EECF244321}">
-                <p14:modId xmlns:p14="http://schemas.microsoft.com/office/powerpoint/2010/main" val="1586770807"/>
-              </p:ext>
-            </p:extLst>
-          </p:nvPr>
-        </p:nvGraphicFramePr>
-        <p:xfrm>
-          <a:off x="4738766" y="4245847"/>
-          <a:ext cx="2687637" cy="995362"/>
-        </p:xfrm>
-        <a:graphic>
-          <a:graphicData uri="http://schemas.openxmlformats.org/presentationml/2006/ole">
-            <mc:AlternateContent xmlns:mc="http://schemas.openxmlformats.org/markup-compatibility/2006">
-              <mc:Choice xmlns:v="urn:schemas-microsoft-com:vml" Requires="v">
-                <p:oleObj name="Equation" r:id="rId5" imgW="1371600" imgH="508000" progId="Equation.DSMT4">
-                  <p:embed/>
-                </p:oleObj>
-              </mc:Choice>
-              <mc:Fallback>
-                <p:oleObj name="Equation" r:id="rId5" imgW="1371600" imgH="508000" progId="Equation.DSMT4">
-                  <p:embed/>
-                  <p:pic>
-                    <p:nvPicPr>
-                      <p:cNvPr id="0" name=""/>
-                      <p:cNvPicPr>
-                        <a:picLocks noChangeAspect="1" noChangeArrowheads="1"/>
-                      </p:cNvPicPr>
-                      <p:nvPr/>
-                    </p:nvPicPr>
-                    <p:blipFill>
-                      <a:blip r:embed="rId6">
-                        <a:extLst>
-                          <a:ext uri="{28A0092B-C50C-407E-A947-70E740481C1C}">
-                            <a14:useLocalDpi xmlns:a14="http://schemas.microsoft.com/office/drawing/2010/main" val="0"/>
-                          </a:ext>
-                        </a:extLst>
-                      </a:blip>
-                      <a:srcRect/>
-                      <a:stretch>
-                        <a:fillRect/>
-                      </a:stretch>
-                    </p:blipFill>
-                    <p:spPr bwMode="auto">
-                      <a:xfrm>
-                        <a:off x="4738766" y="4245847"/>
-                        <a:ext cx="2687637" cy="995362"/>
-                      </a:xfrm>
-                      <a:prstGeom prst="rect">
-                        <a:avLst/>
-                      </a:prstGeom>
-                      <a:noFill/>
-                      <a:ln>
-                        <a:noFill/>
-                      </a:ln>
-                      <a:effectLst/>
-                      <a:extLst>
-                        <a:ext uri="{909E8E84-426E-40DD-AFC4-6F175D3DCCD1}">
-                          <a14:hiddenFill xmlns:a14="http://schemas.microsoft.com/office/drawing/2010/main">
-                            <a:solidFill>
-                              <a:srgbClr val="FFFFFF"/>
-                            </a:solidFill>
-                          </a14:hiddenFill>
-                        </a:ext>
-                        <a:ext uri="{91240B29-F687-4F45-9708-019B960494DF}">
-                          <a14:hiddenLine xmlns:a14="http://schemas.microsoft.com/office/drawing/2010/main" w="9525">
-                            <a:solidFill>
-                              <a:srgbClr val="000000"/>
-                            </a:solidFill>
-                            <a:miter lim="800000"/>
-                            <a:headEnd/>
-                            <a:tailEnd/>
-                          </a14:hiddenLine>
-                        </a:ext>
-                        <a:ext uri="{AF507438-7753-43E0-B8FC-AC1667EBCBE1}">
-                          <a14:hiddenEffects xmlns:a14="http://schemas.microsoft.com/office/drawing/2010/main">
-                            <a:effectLst>
-                              <a:outerShdw dist="35921" dir="2700000" algn="ctr" rotWithShape="0">
-                                <a:srgbClr val="808080"/>
-                              </a:outerShdw>
-                            </a:effectLst>
-                          </a14:hiddenEffects>
-                        </a:ext>
-                      </a:extLst>
-                    </p:spPr>
-                  </p:pic>
-                </p:oleObj>
-              </mc:Fallback>
-            </mc:AlternateContent>
-          </a:graphicData>
-        </a:graphic>
-      </p:graphicFrame>
+      <p:sp>
+        <p:nvSpPr>
+          <p:cNvPr id="238597" name="TextBox 238596"/>
+          <p:cNvSpPr txBox="1"/>
+          <p:nvPr/>
+        </p:nvSpPr>
+        <p:spPr>
+          <a:xfrm>
+            <a:off x="4752976" y="2058757"/>
+            <a:ext cx="1688123" cy="411162"/>
+          </a:xfrm>
+          <a:prstGeom prst="rect">
+            <a:avLst/>
+          </a:prstGeom>
+          <a:noFill/>
+        </p:spPr>
+        <p:txBody>
+          <a:bodyPr wrap="square" anchor="ctr" lIns="0" rIns="0" tIns="0" bIns="0">
+            <a:spAutoFit/>
+          </a:bodyPr>
+          <a:lstStyle/>
+          <a:p>
+            <a:r>
+              <a:rPr sz="1900">
+                <a:latin typeface="Cambria"/>
+              </a:rPr>
+              <a:t>X ~ N(μ, σ</a:t>
+            </a:r>
+            <a:r>
+              <a:rPr sz="1900" baseline="30000">
+                <a:latin typeface="Cambria"/>
+              </a:rPr>
+              <a:t>2</a:t>
+            </a:r>
+            <a:r>
+              <a:rPr sz="1900">
+                <a:latin typeface="Cambria"/>
+              </a:rPr>
+              <a:t>)</a:t>
+            </a:r>
+          </a:p>
+        </p:txBody>
+      </p:sp>
+      <p:sp>
+        <p:nvSpPr>
+          <p:cNvPr id="238598" name="TextBox 238597"/>
+          <p:cNvSpPr txBox="1"/>
+          <p:nvPr/>
+        </p:nvSpPr>
+        <p:spPr>
+          <a:xfrm>
+            <a:off x="4738766" y="4245847"/>
+            <a:ext cx="6611815" cy="995362"/>
+          </a:xfrm>
+          <a:prstGeom prst="rect">
+            <a:avLst/>
+          </a:prstGeom>
+          <a:noFill/>
+        </p:spPr>
+        <p:txBody>
+          <a:bodyPr wrap="square" anchor="ctr" lIns="0" rIns="0" tIns="0" bIns="0">
+            <a:spAutoFit/>
+          </a:bodyPr>
+          <a:lstStyle/>
+          <a:p>
+            <a:r>
+              <a:rPr sz="1900">
+                <a:latin typeface="Cambria"/>
+              </a:rPr>
+              <a:t>f(x) = 1 / (√(2π) σ) · exp( −(x − μ)</a:t>
+            </a:r>
+            <a:r>
+              <a:rPr sz="1900" baseline="30000">
+                <a:latin typeface="Cambria"/>
+              </a:rPr>
+              <a:t>2</a:t>
+            </a:r>
+            <a:r>
+              <a:rPr sz="1900">
+                <a:latin typeface="Cambria"/>
+              </a:rPr>
+              <a:t> / (2σ</a:t>
+            </a:r>
+            <a:r>
+              <a:rPr sz="1900" baseline="30000">
+                <a:latin typeface="Cambria"/>
+              </a:rPr>
+              <a:t>2</a:t>
+            </a:r>
+            <a:r>
+              <a:rPr sz="1900">
+                <a:latin typeface="Cambria"/>
+              </a:rPr>
+              <a:t>) )</a:t>
+            </a:r>
+          </a:p>
+        </p:txBody>
+      </p:sp>
     </p:spTree>
     <p:extLst>
       <p:ext uri="{BB962C8B-B14F-4D97-AF65-F5344CB8AC3E}">
@@ -7754,10 +7650,8 @@
               <a:t> </a:t>
             </a:r>
             <a:r>
-              <a:rPr lang="en-US" altLang="en-US" dirty="0">
-                <a:sym typeface="Symbol" charset="2"/>
-              </a:rPr>
-              <a:t>X  x]</a:t>
+              <a:rPr lang="en-US" altLang="en-US" dirty="0"/>
+              <a:t>X ≤ x]</a:t>
             </a:r>
           </a:p>
         </p:txBody>
@@ -7915,10 +7809,8 @@
               <a:t> </a:t>
             </a:r>
             <a:r>
-              <a:rPr lang="en-US" altLang="en-US" dirty="0">
-                <a:sym typeface="Symbol" charset="2"/>
-              </a:rPr>
-              <a:t>X  x]</a:t>
+              <a:rPr lang="en-US" altLang="en-US" dirty="0"/>
+              <a:t>X ≤ x]</a:t>
             </a:r>
           </a:p>
           <a:p>
@@ -9661,10 +9553,8 @@
               <a:t> 68% lies between </a:t>
             </a:r>
             <a:r>
-              <a:rPr lang="en-US" altLang="en-US" sz="2000" dirty="0">
-                <a:sym typeface="Symbol" charset="2"/>
-              </a:rPr>
-              <a:t>- and +</a:t>
+              <a:rPr lang="en-US" altLang="en-US" sz="2000" dirty="0"/>
+              <a:t>μ-σ and μ+σ</a:t>
             </a:r>
             <a:r>
               <a:rPr lang="en-US" altLang="en-US" sz="2000" dirty="0"/>
@@ -9680,10 +9570,8 @@
               <a:t> 95% lies between </a:t>
             </a:r>
             <a:r>
-              <a:rPr lang="en-US" altLang="en-US" sz="2000" dirty="0">
-                <a:sym typeface="Symbol" charset="2"/>
-              </a:rPr>
-              <a:t>-2 and +2</a:t>
+              <a:rPr lang="en-US" altLang="en-US" sz="2000" dirty="0"/>
+              <a:t>μ-2σ and μ+2σ</a:t>
             </a:r>
           </a:p>
           <a:p>
@@ -9701,10 +9589,8 @@
               <a:t>lies between </a:t>
             </a:r>
             <a:r>
-              <a:rPr lang="en-US" altLang="en-US" sz="2000" dirty="0">
-                <a:sym typeface="Symbol" charset="2"/>
-              </a:rPr>
-              <a:t>-3 and +3</a:t>
+              <a:rPr lang="en-US" altLang="en-US" sz="2000" dirty="0"/>
+              <a:t>μ-3σ and μ+3σ</a:t>
             </a:r>
             <a:endParaRPr lang="en-US" altLang="en-US" sz="2000" dirty="0"/>
           </a:p>
@@ -10828,101 +10714,6 @@
           </a:p>
         </p:txBody>
       </p:sp>
-      <p:graphicFrame>
-        <p:nvGraphicFramePr>
-          <p:cNvPr id="250884" name="Object 5"/>
-          <p:cNvGraphicFramePr>
-            <a:graphicFrameLocks noGrp="1" noChangeAspect="1"/>
-          </p:cNvGraphicFramePr>
-          <p:nvPr>
-            <p:ph sz="half" idx="2"/>
-          </p:nvPr>
-        </p:nvGraphicFramePr>
-        <p:xfrm>
-          <a:off x="3594100" y="3497263"/>
-          <a:ext cx="4724400" cy="1077912"/>
-        </p:xfrm>
-        <a:graphic>
-          <a:graphicData uri="http://schemas.openxmlformats.org/presentationml/2006/ole">
-            <mc:AlternateContent xmlns:mc="http://schemas.openxmlformats.org/markup-compatibility/2006">
-              <mc:Choice xmlns:v="urn:schemas-microsoft-com:vml" Requires="v">
-                <p:oleObj name="Equation" r:id="rId3" imgW="1892300" imgH="431800" progId="Equation.DSMT4">
-                  <p:embed/>
-                </p:oleObj>
-              </mc:Choice>
-              <mc:Fallback>
-                <p:oleObj name="Equation" r:id="rId3" imgW="1892300" imgH="431800" progId="Equation.DSMT4">
-                  <p:embed/>
-                  <p:pic>
-                    <p:nvPicPr>
-                      <p:cNvPr id="0" name=""/>
-                      <p:cNvPicPr>
-                        <a:picLocks noChangeAspect="1" noChangeArrowheads="1"/>
-                      </p:cNvPicPr>
-                      <p:nvPr/>
-                    </p:nvPicPr>
-                    <p:blipFill>
-                      <a:blip r:embed="rId4">
-                        <a:extLst>
-                          <a:ext uri="{28A0092B-C50C-407E-A947-70E740481C1C}">
-                            <a14:useLocalDpi xmlns:a14="http://schemas.microsoft.com/office/drawing/2010/main" val="0"/>
-                          </a:ext>
-                        </a:extLst>
-                      </a:blip>
-                      <a:srcRect/>
-                      <a:stretch>
-                        <a:fillRect/>
-                      </a:stretch>
-                    </p:blipFill>
-                    <p:spPr bwMode="auto">
-                      <a:xfrm>
-                        <a:off x="3594100" y="3497263"/>
-                        <a:ext cx="4724400" cy="1077912"/>
-                      </a:xfrm>
-                      <a:prstGeom prst="rect">
-                        <a:avLst/>
-                      </a:prstGeom>
-                      <a:noFill/>
-                      <a:ln>
-                        <a:noFill/>
-                      </a:ln>
-                      <a:effectLst/>
-                      <a:extLst>
-                        <a:ext uri="{909E8E84-426E-40DD-AFC4-6F175D3DCCD1}">
-                          <a14:hiddenFill xmlns:a14="http://schemas.microsoft.com/office/drawing/2010/main">
-                            <a:solidFill>
-                              <a:srgbClr val="FFFFFF"/>
-                            </a:solidFill>
-                          </a14:hiddenFill>
-                        </a:ext>
-                        <a:ext uri="{91240B29-F687-4F45-9708-019B960494DF}">
-                          <a14:hiddenLine xmlns:a14="http://schemas.microsoft.com/office/drawing/2010/main" w="9525">
-                            <a:solidFill>
-                              <a:srgbClr val="000000"/>
-                            </a:solidFill>
-                            <a:miter lim="800000"/>
-                            <a:headEnd/>
-                            <a:tailEnd/>
-                          </a14:hiddenLine>
-                        </a:ext>
-                        <a:ext uri="{AF507438-7753-43E0-B8FC-AC1667EBCBE1}">
-                          <a14:hiddenEffects xmlns:a14="http://schemas.microsoft.com/office/drawing/2010/main">
-                            <a:effectLst>
-                              <a:outerShdw dist="35921" dir="2700000" algn="ctr" rotWithShape="0">
-                                <a:srgbClr val="808080"/>
-                              </a:outerShdw>
-                            </a:effectLst>
-                          </a14:hiddenEffects>
-                        </a:ext>
-                      </a:extLst>
-                    </p:spPr>
-                  </p:pic>
-                </p:oleObj>
-              </mc:Fallback>
-            </mc:AlternateContent>
-          </a:graphicData>
-        </a:graphic>
-      </p:graphicFrame>
       <p:sp>
         <p:nvSpPr>
           <p:cNvPr id="250885" name="TextBox 1"/>
@@ -11176,10 +10967,8 @@
               <a:t> = </a:t>
             </a:r>
             <a:r>
-              <a:rPr lang="en-US" altLang="en-US" sz="2400" dirty="0">
-                <a:sym typeface="Symbol" charset="2"/>
-              </a:rPr>
-              <a:t> + </a:t>
+              <a:rPr lang="en-US" altLang="en-US" sz="2400" dirty="0"/>
+              <a:t>μ + σ</a:t>
             </a:r>
             <a:r>
               <a:rPr lang="en-US" altLang="en-US" sz="2400" i="1" dirty="0">
@@ -11188,6 +10977,37 @@
               <a:t>z</a:t>
             </a:r>
             <a:endParaRPr lang="en-US" altLang="en-US" sz="2400" i="1" dirty="0"/>
+          </a:p>
+        </p:txBody>
+      </p:sp>
+      <p:sp>
+        <p:nvSpPr>
+          <p:cNvPr id="250886" name="TextBox 250885"/>
+          <p:cNvSpPr txBox="1"/>
+          <p:nvPr/>
+        </p:nvSpPr>
+        <p:spPr>
+          <a:xfrm>
+            <a:off x="3594100" y="3497263"/>
+            <a:ext cx="7737230" cy="1077912"/>
+          </a:xfrm>
+          <a:prstGeom prst="rect">
+            <a:avLst/>
+          </a:prstGeom>
+          <a:noFill/>
+        </p:spPr>
+        <p:txBody>
+          <a:bodyPr wrap="square" anchor="ctr" lIns="0" rIns="0" tIns="0" bIns="0">
+            <a:spAutoFit/>
+          </a:bodyPr>
+          <a:lstStyle/>
+          <a:p>
+            <a:r>
+              <a:rPr sz="1900">
+                <a:latin typeface="Cambria"/>
+              </a:rPr>
+              <a:t>z = (value − mean) / (standard deviation) = (x − μ) / σ</a:t>
+            </a:r>
           </a:p>
         </p:txBody>
       </p:sp>
@@ -11306,10 +11126,8 @@
               <a:t> </a:t>
             </a:r>
             <a:r>
-              <a:rPr lang="en-US" altLang="en-US" dirty="0">
-                <a:sym typeface="Symbol" charset="2"/>
-              </a:rPr>
-              <a:t> </a:t>
+              <a:rPr lang="en-US" altLang="en-US" dirty="0"/>
+              <a:t>≤ </a:t>
             </a:r>
             <a:r>
               <a:rPr lang="en-US" altLang="en-US" dirty="0"/>
@@ -11329,10 +11147,8 @@
               <a:t>  </a:t>
             </a:r>
             <a:r>
-              <a:rPr lang="en-US" altLang="en-US" dirty="0">
-                <a:sym typeface="Symbol" charset="2"/>
-              </a:rPr>
-              <a:t></a:t>
+              <a:rPr lang="en-US" altLang="en-US" dirty="0"/>
+              <a:t>≥</a:t>
             </a:r>
             <a:r>
               <a:rPr lang="en-US" altLang="en-US" dirty="0"/>
@@ -11348,10 +11164,8 @@
               <a:t>0.1 </a:t>
             </a:r>
             <a:r>
-              <a:rPr lang="en-US" altLang="en-US" dirty="0">
-                <a:sym typeface="Symbol" charset="2"/>
-              </a:rPr>
-              <a:t></a:t>
+              <a:rPr lang="en-US" altLang="en-US" dirty="0"/>
+              <a:t>≤</a:t>
             </a:r>
             <a:r>
               <a:rPr lang="en-US" altLang="en-US" dirty="0"/>
@@ -11366,10 +11180,8 @@
               <a:t> </a:t>
             </a:r>
             <a:r>
-              <a:rPr lang="en-US" altLang="en-US" dirty="0">
-                <a:sym typeface="Symbol" charset="2"/>
-              </a:rPr>
-              <a:t> 0.5 OR 1.5  </a:t>
+              <a:rPr lang="en-US" altLang="en-US" dirty="0"/>
+              <a:t>≤ 0.5 OR 1.5 ≤ </a:t>
             </a:r>
             <a:r>
               <a:rPr lang="en-US" altLang="en-US" i="1" dirty="0">
@@ -11378,10 +11190,8 @@
               <a:t>X </a:t>
             </a:r>
             <a:r>
-              <a:rPr lang="en-US" altLang="en-US" dirty="0">
-                <a:sym typeface="Symbol" charset="2"/>
-              </a:rPr>
-              <a:t> 2</a:t>
+              <a:rPr lang="en-US" altLang="en-US" dirty="0"/>
+              <a:t>≤ 2</a:t>
             </a:r>
           </a:p>
           <a:p>
@@ -13541,7 +13351,23 @@
             </a:pPr>
             <a:r>
               <a:rPr lang="en-US" altLang="en-US" dirty="0"/>
-              <a:t>      is often called the </a:t>
+              <a:t/>
+            </a:r>
+            <a:r>
+              <a:rPr lang="en-US" altLang="en-US" dirty="0">
+                <a:latin typeface="Cambria"/>
+              </a:rPr>
+              <a:t>σ</a:t>
+            </a:r>
+            <a:r>
+              <a:rPr lang="en-US" altLang="en-US" dirty="0" baseline="-25000">
+                <a:latin typeface="Cambria"/>
+              </a:rPr>
+              <a:t>x̄</a:t>
+            </a:r>
+            <a:r>
+              <a:rPr lang="en-US" altLang="en-US" dirty="0"/>
+              <a:t> is often called the </a:t>
             </a:r>
             <a:r>
               <a:rPr lang="en-US" altLang="en-US" b="1" dirty="0">
@@ -13559,307 +13385,92 @@
           </a:p>
         </p:txBody>
       </p:sp>
-      <p:graphicFrame>
-        <p:nvGraphicFramePr>
-          <p:cNvPr id="263171" name="Object 5"/>
-          <p:cNvGraphicFramePr>
-            <a:graphicFrameLocks noGrp="1" noChangeAspect="1"/>
-          </p:cNvGraphicFramePr>
-          <p:nvPr>
-            <p:ph sz="quarter" idx="2"/>
-            <p:extLst>
-              <p:ext uri="{D42A27DB-BD31-4B8C-83A1-F6EECF244321}">
-                <p14:modId xmlns:p14="http://schemas.microsoft.com/office/powerpoint/2010/main" val="245028359"/>
-              </p:ext>
-            </p:extLst>
-          </p:nvPr>
-        </p:nvGraphicFramePr>
-        <p:xfrm>
-          <a:off x="5402264" y="2347338"/>
-          <a:ext cx="941387" cy="457200"/>
-        </p:xfrm>
-        <a:graphic>
-          <a:graphicData uri="http://schemas.openxmlformats.org/presentationml/2006/ole">
-            <mc:AlternateContent xmlns:mc="http://schemas.openxmlformats.org/markup-compatibility/2006">
-              <mc:Choice xmlns:v="urn:schemas-microsoft-com:vml" Requires="v">
-                <p:oleObj name="Equation" r:id="rId3" imgW="469900" imgH="228600" progId="Equation.DSMT4">
-                  <p:embed/>
-                </p:oleObj>
-              </mc:Choice>
-              <mc:Fallback>
-                <p:oleObj name="Equation" r:id="rId3" imgW="469900" imgH="228600" progId="Equation.DSMT4">
-                  <p:embed/>
-                  <p:pic>
-                    <p:nvPicPr>
-                      <p:cNvPr id="0" name=""/>
-                      <p:cNvPicPr>
-                        <a:picLocks noChangeAspect="1" noChangeArrowheads="1"/>
-                      </p:cNvPicPr>
-                      <p:nvPr/>
-                    </p:nvPicPr>
-                    <p:blipFill>
-                      <a:blip r:embed="rId4">
-                        <a:extLst>
-                          <a:ext uri="{28A0092B-C50C-407E-A947-70E740481C1C}">
-                            <a14:useLocalDpi xmlns:a14="http://schemas.microsoft.com/office/drawing/2010/main" val="0"/>
-                          </a:ext>
-                        </a:extLst>
-                      </a:blip>
-                      <a:srcRect/>
-                      <a:stretch>
-                        <a:fillRect/>
-                      </a:stretch>
-                    </p:blipFill>
-                    <p:spPr bwMode="auto">
-                      <a:xfrm>
-                        <a:off x="5402264" y="2347338"/>
-                        <a:ext cx="941387" cy="457200"/>
-                      </a:xfrm>
-                      <a:prstGeom prst="rect">
-                        <a:avLst/>
-                      </a:prstGeom>
-                      <a:noFill/>
-                      <a:ln>
-                        <a:noFill/>
-                      </a:ln>
-                      <a:effectLst/>
-                      <a:extLst>
-                        <a:ext uri="{909E8E84-426E-40DD-AFC4-6F175D3DCCD1}">
-                          <a14:hiddenFill xmlns:a14="http://schemas.microsoft.com/office/drawing/2010/main">
-                            <a:solidFill>
-                              <a:srgbClr val="FFFFFF"/>
-                            </a:solidFill>
-                          </a14:hiddenFill>
-                        </a:ext>
-                        <a:ext uri="{91240B29-F687-4F45-9708-019B960494DF}">
-                          <a14:hiddenLine xmlns:a14="http://schemas.microsoft.com/office/drawing/2010/main" w="9525">
-                            <a:solidFill>
-                              <a:srgbClr val="000000"/>
-                            </a:solidFill>
-                            <a:miter lim="800000"/>
-                            <a:headEnd/>
-                            <a:tailEnd/>
-                          </a14:hiddenLine>
-                        </a:ext>
-                        <a:ext uri="{AF507438-7753-43E0-B8FC-AC1667EBCBE1}">
-                          <a14:hiddenEffects xmlns:a14="http://schemas.microsoft.com/office/drawing/2010/main">
-                            <a:effectLst>
-                              <a:outerShdw dist="35921" dir="2700000" algn="ctr" rotWithShape="0">
-                                <a:srgbClr val="808080"/>
-                              </a:outerShdw>
-                            </a:effectLst>
-                          </a14:hiddenEffects>
-                        </a:ext>
-                      </a:extLst>
-                    </p:spPr>
-                  </p:pic>
-                </p:oleObj>
-              </mc:Fallback>
-            </mc:AlternateContent>
-          </a:graphicData>
-        </a:graphic>
-      </p:graphicFrame>
-      <p:graphicFrame>
-        <p:nvGraphicFramePr>
-          <p:cNvPr id="263172" name="Object 7"/>
-          <p:cNvGraphicFramePr>
-            <a:graphicFrameLocks noGrp="1" noChangeAspect="1"/>
-          </p:cNvGraphicFramePr>
-          <p:nvPr>
-            <p:ph sz="quarter" idx="3"/>
-            <p:extLst>
-              <p:ext uri="{D42A27DB-BD31-4B8C-83A1-F6EECF244321}">
-                <p14:modId xmlns:p14="http://schemas.microsoft.com/office/powerpoint/2010/main" val="1443483951"/>
-              </p:ext>
-            </p:extLst>
-          </p:nvPr>
-        </p:nvGraphicFramePr>
-        <p:xfrm>
-          <a:off x="5029686" y="4162887"/>
-          <a:ext cx="1508125" cy="511175"/>
-        </p:xfrm>
-        <a:graphic>
-          <a:graphicData uri="http://schemas.openxmlformats.org/presentationml/2006/ole">
-            <mc:AlternateContent xmlns:mc="http://schemas.openxmlformats.org/markup-compatibility/2006">
-              <mc:Choice xmlns:v="urn:schemas-microsoft-com:vml" Requires="v">
-                <p:oleObj name="Equation" r:id="rId5" imgW="748975" imgH="253890" progId="Equation.DSMT4">
-                  <p:embed/>
-                </p:oleObj>
-              </mc:Choice>
-              <mc:Fallback>
-                <p:oleObj name="Equation" r:id="rId5" imgW="748975" imgH="253890" progId="Equation.DSMT4">
-                  <p:embed/>
-                  <p:pic>
-                    <p:nvPicPr>
-                      <p:cNvPr id="0" name=""/>
-                      <p:cNvPicPr>
-                        <a:picLocks noChangeAspect="1" noChangeArrowheads="1"/>
-                      </p:cNvPicPr>
-                      <p:nvPr/>
-                    </p:nvPicPr>
-                    <p:blipFill>
-                      <a:blip r:embed="rId6">
-                        <a:extLst>
-                          <a:ext uri="{28A0092B-C50C-407E-A947-70E740481C1C}">
-                            <a14:useLocalDpi xmlns:a14="http://schemas.microsoft.com/office/drawing/2010/main" val="0"/>
-                          </a:ext>
-                        </a:extLst>
-                      </a:blip>
-                      <a:srcRect/>
-                      <a:stretch>
-                        <a:fillRect/>
-                      </a:stretch>
-                    </p:blipFill>
-                    <p:spPr bwMode="auto">
-                      <a:xfrm>
-                        <a:off x="5029686" y="4162887"/>
-                        <a:ext cx="1508125" cy="511175"/>
-                      </a:xfrm>
-                      <a:prstGeom prst="rect">
-                        <a:avLst/>
-                      </a:prstGeom>
-                      <a:noFill/>
-                      <a:ln>
-                        <a:noFill/>
-                      </a:ln>
-                      <a:effectLst/>
-                      <a:extLst>
-                        <a:ext uri="{909E8E84-426E-40DD-AFC4-6F175D3DCCD1}">
-                          <a14:hiddenFill xmlns:a14="http://schemas.microsoft.com/office/drawing/2010/main">
-                            <a:solidFill>
-                              <a:srgbClr val="FFFFFF"/>
-                            </a:solidFill>
-                          </a14:hiddenFill>
-                        </a:ext>
-                        <a:ext uri="{91240B29-F687-4F45-9708-019B960494DF}">
-                          <a14:hiddenLine xmlns:a14="http://schemas.microsoft.com/office/drawing/2010/main" w="9525">
-                            <a:solidFill>
-                              <a:srgbClr val="000000"/>
-                            </a:solidFill>
-                            <a:miter lim="800000"/>
-                            <a:headEnd/>
-                            <a:tailEnd/>
-                          </a14:hiddenLine>
-                        </a:ext>
-                        <a:ext uri="{AF507438-7753-43E0-B8FC-AC1667EBCBE1}">
-                          <a14:hiddenEffects xmlns:a14="http://schemas.microsoft.com/office/drawing/2010/main">
-                            <a:effectLst>
-                              <a:outerShdw dist="35921" dir="2700000" algn="ctr" rotWithShape="0">
-                                <a:srgbClr val="808080"/>
-                              </a:outerShdw>
-                            </a:effectLst>
-                          </a14:hiddenEffects>
-                        </a:ext>
-                      </a:extLst>
-                    </p:spPr>
-                  </p:pic>
-                </p:oleObj>
-              </mc:Fallback>
-            </mc:AlternateContent>
-          </a:graphicData>
-        </a:graphic>
-      </p:graphicFrame>
-      <p:graphicFrame>
-        <p:nvGraphicFramePr>
-          <p:cNvPr id="263173" name="Object 9"/>
-          <p:cNvGraphicFramePr>
-            <a:graphicFrameLocks noChangeAspect="1"/>
-          </p:cNvGraphicFramePr>
-          <p:nvPr>
-            <p:extLst>
-              <p:ext uri="{D42A27DB-BD31-4B8C-83A1-F6EECF244321}">
-                <p14:modId xmlns:p14="http://schemas.microsoft.com/office/powerpoint/2010/main" val="8511365"/>
-              </p:ext>
-            </p:extLst>
-          </p:nvPr>
-        </p:nvGraphicFramePr>
-        <p:xfrm>
-          <a:off x="1425401" y="4988138"/>
-          <a:ext cx="401637" cy="452437"/>
-        </p:xfrm>
-        <a:graphic>
-          <a:graphicData uri="http://schemas.openxmlformats.org/presentationml/2006/ole">
-            <mc:AlternateContent xmlns:mc="http://schemas.openxmlformats.org/markup-compatibility/2006">
-              <mc:Choice xmlns:v="urn:schemas-microsoft-com:vml" Requires="v">
-                <p:oleObj name="Equation" r:id="rId7" imgW="203112" imgH="228501" progId="Equation.DSMT4">
-                  <p:embed/>
-                </p:oleObj>
-              </mc:Choice>
-              <mc:Fallback>
-                <p:oleObj name="Equation" r:id="rId7" imgW="203112" imgH="228501" progId="Equation.DSMT4">
-                  <p:embed/>
-                  <p:pic>
-                    <p:nvPicPr>
-                      <p:cNvPr id="0" name=""/>
-                      <p:cNvPicPr>
-                        <a:picLocks noChangeAspect="1" noChangeArrowheads="1"/>
-                      </p:cNvPicPr>
-                      <p:nvPr/>
-                    </p:nvPicPr>
-                    <p:blipFill>
-                      <a:blip r:embed="rId8">
-                        <a:extLst>
-                          <a:ext uri="{28A0092B-C50C-407E-A947-70E740481C1C}">
-                            <a14:useLocalDpi xmlns:a14="http://schemas.microsoft.com/office/drawing/2010/main" val="0"/>
-                          </a:ext>
-                        </a:extLst>
-                      </a:blip>
-                      <a:srcRect/>
-                      <a:stretch>
-                        <a:fillRect/>
-                      </a:stretch>
-                    </p:blipFill>
-                    <p:spPr bwMode="auto">
-                      <a:xfrm>
-                        <a:off x="1425401" y="4988138"/>
-                        <a:ext cx="401637" cy="452437"/>
-                      </a:xfrm>
-                      <a:prstGeom prst="rect">
-                        <a:avLst/>
-                      </a:prstGeom>
-                      <a:noFill/>
-                      <a:ln>
-                        <a:noFill/>
-                      </a:ln>
-                      <a:effectLst/>
-                      <a:extLst>
-                        <a:ext uri="{909E8E84-426E-40DD-AFC4-6F175D3DCCD1}">
-                          <a14:hiddenFill xmlns:a14="http://schemas.microsoft.com/office/drawing/2010/main">
-                            <a:solidFill>
-                              <a:srgbClr val="FFFFFF"/>
-                            </a:solidFill>
-                          </a14:hiddenFill>
-                        </a:ext>
-                        <a:ext uri="{91240B29-F687-4F45-9708-019B960494DF}">
-                          <a14:hiddenLine xmlns:a14="http://schemas.microsoft.com/office/drawing/2010/main" w="9525">
-                            <a:solidFill>
-                              <a:srgbClr val="000000"/>
-                            </a:solidFill>
-                            <a:miter lim="800000"/>
-                            <a:headEnd/>
-                            <a:tailEnd/>
-                          </a14:hiddenLine>
-                        </a:ext>
-                        <a:ext uri="{AF507438-7753-43E0-B8FC-AC1667EBCBE1}">
-                          <a14:hiddenEffects xmlns:a14="http://schemas.microsoft.com/office/drawing/2010/main">
-                            <a:effectLst>
-                              <a:outerShdw blurRad="63500" dist="38099" dir="2700000" algn="ctr" rotWithShape="0">
-                                <a:srgbClr val="000000">
-                                  <a:alpha val="74997"/>
-                                </a:srgbClr>
-                              </a:outerShdw>
-                            </a:effectLst>
-                          </a14:hiddenEffects>
-                        </a:ext>
-                      </a:extLst>
-                    </p:spPr>
-                  </p:pic>
-                </p:oleObj>
-              </mc:Fallback>
-            </mc:AlternateContent>
-          </a:graphicData>
-        </a:graphic>
-      </p:graphicFrame>
+      <p:sp>
+        <p:nvSpPr>
+          <p:cNvPr id="263174" name="TextBox 263173"/>
+          <p:cNvSpPr txBox="1"/>
+          <p:nvPr/>
+        </p:nvSpPr>
+        <p:spPr>
+          <a:xfrm>
+            <a:off x="5402264" y="2347338"/>
+            <a:ext cx="984738" cy="457200"/>
+          </a:xfrm>
+          <a:prstGeom prst="rect">
+            <a:avLst/>
+          </a:prstGeom>
+          <a:noFill/>
+        </p:spPr>
+        <p:txBody>
+          <a:bodyPr wrap="square" anchor="ctr" lIns="0" rIns="0" tIns="0" bIns="0">
+            <a:spAutoFit/>
+          </a:bodyPr>
+          <a:lstStyle/>
+          <a:p>
+            <a:r>
+              <a:rPr sz="1900">
+                <a:latin typeface="Cambria"/>
+              </a:rPr>
+              <a:t>μ</a:t>
+            </a:r>
+            <a:r>
+              <a:rPr sz="1900" baseline="-25000">
+                <a:latin typeface="Cambria"/>
+              </a:rPr>
+              <a:t>x̄</a:t>
+            </a:r>
+            <a:r>
+              <a:rPr sz="1900">
+                <a:latin typeface="Cambria"/>
+              </a:rPr>
+              <a:t> = μ</a:t>
+            </a:r>
+          </a:p>
+        </p:txBody>
+      </p:sp>
+      <p:sp>
+        <p:nvSpPr>
+          <p:cNvPr id="263175" name="TextBox 263174"/>
+          <p:cNvSpPr txBox="1"/>
+          <p:nvPr/>
+        </p:nvSpPr>
+        <p:spPr>
+          <a:xfrm>
+            <a:off x="5029686" y="4162887"/>
+            <a:ext cx="1688123" cy="511175"/>
+          </a:xfrm>
+          <a:prstGeom prst="rect">
+            <a:avLst/>
+          </a:prstGeom>
+          <a:noFill/>
+        </p:spPr>
+        <p:txBody>
+          <a:bodyPr wrap="square" anchor="ctr" lIns="0" rIns="0" tIns="0" bIns="0">
+            <a:spAutoFit/>
+          </a:bodyPr>
+          <a:lstStyle/>
+          <a:p>
+            <a:r>
+              <a:rPr sz="1900">
+                <a:latin typeface="Cambria"/>
+              </a:rPr>
+              <a:t>σ</a:t>
+            </a:r>
+            <a:r>
+              <a:rPr sz="1900" baseline="-25000">
+                <a:latin typeface="Cambria"/>
+              </a:rPr>
+              <a:t>x̄</a:t>
+            </a:r>
+            <a:r>
+              <a:rPr sz="1900">
+                <a:latin typeface="Cambria"/>
+              </a:rPr>
+              <a:t> = σ / √n</a:t>
+            </a:r>
+          </a:p>
+        </p:txBody>
+      </p:sp>
     </p:spTree>
     <p:extLst>
       <p:ext uri="{BB962C8B-B14F-4D97-AF65-F5344CB8AC3E}">
@@ -14004,10 +13615,8 @@
               <a:t>n </a:t>
             </a:r>
             <a:r>
-              <a:rPr lang="en-US" altLang="en-US" dirty="0">
-                <a:sym typeface="Symbol" charset="2"/>
-              </a:rPr>
-              <a:t>~30) are drawn from </a:t>
+              <a:rPr lang="en-US" altLang="en-US" dirty="0"/>
+              <a:t>≥~30) are drawn from </a:t>
             </a:r>
             <a:r>
               <a:rPr lang="en-US" altLang="en-US" i="1" dirty="0">
@@ -14019,10 +13628,8 @@
               <a:t>any</a:t>
             </a:r>
             <a:r>
-              <a:rPr lang="en-US" altLang="en-US" dirty="0">
-                <a:sym typeface="Symbol" charset="2"/>
-              </a:rPr>
-              <a:t> population with a mean  and a standard deviation , the distribution of the means approximates a normal distribution. The greater the sample size, the better the approximation.</a:t>
+              <a:rPr lang="en-US" altLang="en-US" dirty="0"/>
+              <a:t> population with a mean μ and a standard deviation σ, the distribution of the means approximates a normal distribution. The greater the sample size, the better the approximation.</a:t>
             </a:r>
           </a:p>
           <a:p>
@@ -14943,10 +14550,8 @@
               <a:t> </a:t>
             </a:r>
             <a:r>
-              <a:rPr lang="en-US" altLang="en-US" sz="2000" dirty="0">
-                <a:sym typeface="Symbol" charset="2"/>
-              </a:rPr>
-              <a:t> 5 and </a:t>
+              <a:rPr lang="en-US" altLang="en-US" sz="2000" dirty="0"/>
+              <a:t>≥ 5 and </a:t>
             </a:r>
             <a:r>
               <a:rPr lang="en-US" altLang="en-US" sz="2000" i="1" dirty="0">
@@ -14955,10 +14560,8 @@
               <a:t>nq</a:t>
             </a:r>
             <a:r>
-              <a:rPr lang="en-US" altLang="en-US" sz="2000" dirty="0">
-                <a:sym typeface="Symbol" charset="2"/>
-              </a:rPr>
-              <a:t>  5, the binomial random variable </a:t>
+              <a:rPr lang="en-US" altLang="en-US" sz="2000" dirty="0"/>
+              <a:t> ≥ 5, the binomial random variable </a:t>
             </a:r>
             <a:r>
               <a:rPr lang="en-US" altLang="en-US" sz="2000" i="1" dirty="0">
@@ -15038,106 +14641,6 @@
           </a:p>
         </p:txBody>
       </p:sp>
-      <p:graphicFrame>
-        <p:nvGraphicFramePr>
-          <p:cNvPr id="269315" name="Object 4"/>
-          <p:cNvGraphicFramePr>
-            <a:graphicFrameLocks noGrp="1" noChangeAspect="1"/>
-          </p:cNvGraphicFramePr>
-          <p:nvPr>
-            <p:ph sz="half" idx="2"/>
-            <p:extLst>
-              <p:ext uri="{D42A27DB-BD31-4B8C-83A1-F6EECF244321}">
-                <p14:modId xmlns:p14="http://schemas.microsoft.com/office/powerpoint/2010/main" val="1106756332"/>
-              </p:ext>
-            </p:extLst>
-          </p:nvPr>
-        </p:nvGraphicFramePr>
-        <p:xfrm>
-          <a:off x="4487831" y="3537745"/>
-          <a:ext cx="2286000" cy="512762"/>
-        </p:xfrm>
-        <a:graphic>
-          <a:graphicData uri="http://schemas.openxmlformats.org/presentationml/2006/ole">
-            <mc:AlternateContent xmlns:mc="http://schemas.openxmlformats.org/markup-compatibility/2006">
-              <mc:Choice xmlns:v="urn:schemas-microsoft-com:vml" Requires="v">
-                <p:oleObj name="Equation" r:id="rId3" imgW="1129810" imgH="253890" progId="Equation.DSMT4">
-                  <p:embed/>
-                </p:oleObj>
-              </mc:Choice>
-              <mc:Fallback>
-                <p:oleObj name="Equation" r:id="rId3" imgW="1129810" imgH="253890" progId="Equation.DSMT4">
-                  <p:embed/>
-                  <p:pic>
-                    <p:nvPicPr>
-                      <p:cNvPr id="0" name=""/>
-                      <p:cNvPicPr>
-                        <a:picLocks noChangeAspect="1" noChangeArrowheads="1"/>
-                      </p:cNvPicPr>
-                      <p:nvPr/>
-                    </p:nvPicPr>
-                    <p:blipFill>
-                      <a:blip r:embed="rId4">
-                        <a:extLst>
-                          <a:ext uri="{28A0092B-C50C-407E-A947-70E740481C1C}">
-                            <a14:useLocalDpi xmlns:a14="http://schemas.microsoft.com/office/drawing/2010/main" val="0"/>
-                          </a:ext>
-                        </a:extLst>
-                      </a:blip>
-                      <a:srcRect/>
-                      <a:stretch>
-                        <a:fillRect/>
-                      </a:stretch>
-                    </p:blipFill>
-                    <p:spPr bwMode="auto">
-                      <a:xfrm>
-                        <a:off x="4487831" y="3537745"/>
-                        <a:ext cx="2286000" cy="512762"/>
-                      </a:xfrm>
-                      <a:prstGeom prst="rect">
-                        <a:avLst/>
-                      </a:prstGeom>
-                      <a:noFill/>
-                      <a:ln>
-                        <a:noFill/>
-                      </a:ln>
-                      <a:effectLst/>
-                      <a:extLst>
-                        <a:ext uri="{909E8E84-426E-40DD-AFC4-6F175D3DCCD1}">
-                          <a14:hiddenFill xmlns:a14="http://schemas.microsoft.com/office/drawing/2010/main">
-                            <a:solidFill>
-                              <a:srgbClr val="FFFFFF"/>
-                            </a:solidFill>
-                          </a14:hiddenFill>
-                        </a:ext>
-                        <a:ext uri="{91240B29-F687-4F45-9708-019B960494DF}">
-                          <a14:hiddenLine xmlns:a14="http://schemas.microsoft.com/office/drawing/2010/main" w="9525">
-                            <a:solidFill>
-                              <a:srgbClr val="000000"/>
-                            </a:solidFill>
-                            <a:miter lim="800000"/>
-                            <a:headEnd/>
-                            <a:tailEnd/>
-                          </a14:hiddenLine>
-                        </a:ext>
-                        <a:ext uri="{AF507438-7753-43E0-B8FC-AC1667EBCBE1}">
-                          <a14:hiddenEffects xmlns:a14="http://schemas.microsoft.com/office/drawing/2010/main">
-                            <a:effectLst>
-                              <a:outerShdw dist="35921" dir="2700000" algn="ctr" rotWithShape="0">
-                                <a:srgbClr val="808080"/>
-                              </a:outerShdw>
-                            </a:effectLst>
-                          </a14:hiddenEffects>
-                        </a:ext>
-                      </a:extLst>
-                    </p:spPr>
-                  </p:pic>
-                </p:oleObj>
-              </mc:Fallback>
-            </mc:AlternateContent>
-          </a:graphicData>
-        </a:graphic>
-      </p:graphicFrame>
       <p:sp>
         <p:nvSpPr>
           <p:cNvPr id="2" name="TextBox 1"/>
@@ -15171,6 +14674,37 @@
             <a:r>
               <a:rPr lang="en-US" dirty="0"/>
               <a:t> of a binomial random variable</a:t>
+            </a:r>
+          </a:p>
+        </p:txBody>
+      </p:sp>
+      <p:sp>
+        <p:nvSpPr>
+          <p:cNvPr id="4100" name="TextBox 4099"/>
+          <p:cNvSpPr txBox="1"/>
+          <p:nvPr/>
+        </p:nvSpPr>
+        <p:spPr>
+          <a:xfrm>
+            <a:off x="4487831" y="3537745"/>
+            <a:ext cx="2391507" cy="512762"/>
+          </a:xfrm>
+          <a:prstGeom prst="rect">
+            <a:avLst/>
+          </a:prstGeom>
+          <a:noFill/>
+        </p:spPr>
+        <p:txBody>
+          <a:bodyPr wrap="square" anchor="ctr" lIns="0" rIns="0" tIns="0" bIns="0">
+            <a:spAutoFit/>
+          </a:bodyPr>
+          <a:lstStyle/>
+          <a:p>
+            <a:r>
+              <a:rPr sz="1900">
+                <a:latin typeface="Cambria"/>
+              </a:rPr>
+              <a:t>X ≈ N(np, √(npq))</a:t>
             </a:r>
           </a:p>
         </p:txBody>
@@ -15770,16 +15304,12 @@
               <a:t>If </a:t>
             </a:r>
             <a:r>
-              <a:rPr lang="en-US" altLang="en-US" dirty="0">
-                <a:sym typeface="Symbol" charset="2"/>
-              </a:rPr>
-              <a:t>&gt;10, the Poisson random variable </a:t>
-            </a:r>
-            <a:r>
-              <a:rPr lang="en-US" altLang="en-US" i="1" dirty="0">
-                <a:sym typeface="Symbol" charset="2"/>
-              </a:rPr>
-              <a:t>X ~P()</a:t>
+              <a:rPr lang="en-US" altLang="en-US" dirty="0"/>
+              <a:t>μ&gt;10, the Poisson random variable </a:t>
+            </a:r>
+            <a:r>
+              <a:rPr lang="en-US" altLang="en-US" i="1" dirty="0"/>
+              <a:t>X ~P(μ)</a:t>
             </a:r>
             <a:r>
               <a:rPr lang="en-US" altLang="en-US" dirty="0">
@@ -15806,101 +15336,6 @@
           </a:p>
         </p:txBody>
       </p:sp>
-      <p:graphicFrame>
-        <p:nvGraphicFramePr>
-          <p:cNvPr id="275459" name="Object 4"/>
-          <p:cNvGraphicFramePr>
-            <a:graphicFrameLocks noGrp="1" noChangeAspect="1"/>
-          </p:cNvGraphicFramePr>
-          <p:nvPr>
-            <p:ph sz="half" idx="2"/>
-          </p:nvPr>
-        </p:nvGraphicFramePr>
-        <p:xfrm>
-          <a:off x="4564063" y="4183064"/>
-          <a:ext cx="2590800" cy="700087"/>
-        </p:xfrm>
-        <a:graphic>
-          <a:graphicData uri="http://schemas.openxmlformats.org/presentationml/2006/ole">
-            <mc:AlternateContent xmlns:mc="http://schemas.openxmlformats.org/markup-compatibility/2006">
-              <mc:Choice xmlns:v="urn:schemas-microsoft-com:vml" Requires="v">
-                <p:oleObj name="Equation" r:id="rId3" imgW="939392" imgH="253890" progId="Equation.DSMT4">
-                  <p:embed/>
-                </p:oleObj>
-              </mc:Choice>
-              <mc:Fallback>
-                <p:oleObj name="Equation" r:id="rId3" imgW="939392" imgH="253890" progId="Equation.DSMT4">
-                  <p:embed/>
-                  <p:pic>
-                    <p:nvPicPr>
-                      <p:cNvPr id="0" name=""/>
-                      <p:cNvPicPr>
-                        <a:picLocks noChangeAspect="1" noChangeArrowheads="1"/>
-                      </p:cNvPicPr>
-                      <p:nvPr/>
-                    </p:nvPicPr>
-                    <p:blipFill>
-                      <a:blip r:embed="rId4">
-                        <a:extLst>
-                          <a:ext uri="{28A0092B-C50C-407E-A947-70E740481C1C}">
-                            <a14:useLocalDpi xmlns:a14="http://schemas.microsoft.com/office/drawing/2010/main" val="0"/>
-                          </a:ext>
-                        </a:extLst>
-                      </a:blip>
-                      <a:srcRect/>
-                      <a:stretch>
-                        <a:fillRect/>
-                      </a:stretch>
-                    </p:blipFill>
-                    <p:spPr bwMode="auto">
-                      <a:xfrm>
-                        <a:off x="4564063" y="4183064"/>
-                        <a:ext cx="2590800" cy="700087"/>
-                      </a:xfrm>
-                      <a:prstGeom prst="rect">
-                        <a:avLst/>
-                      </a:prstGeom>
-                      <a:noFill/>
-                      <a:ln>
-                        <a:noFill/>
-                      </a:ln>
-                      <a:effectLst/>
-                      <a:extLst>
-                        <a:ext uri="{909E8E84-426E-40DD-AFC4-6F175D3DCCD1}">
-                          <a14:hiddenFill xmlns:a14="http://schemas.microsoft.com/office/drawing/2010/main">
-                            <a:solidFill>
-                              <a:srgbClr val="FFFFFF"/>
-                            </a:solidFill>
-                          </a14:hiddenFill>
-                        </a:ext>
-                        <a:ext uri="{91240B29-F687-4F45-9708-019B960494DF}">
-                          <a14:hiddenLine xmlns:a14="http://schemas.microsoft.com/office/drawing/2010/main" w="9525">
-                            <a:solidFill>
-                              <a:srgbClr val="000000"/>
-                            </a:solidFill>
-                            <a:miter lim="800000"/>
-                            <a:headEnd/>
-                            <a:tailEnd/>
-                          </a14:hiddenLine>
-                        </a:ext>
-                        <a:ext uri="{AF507438-7753-43E0-B8FC-AC1667EBCBE1}">
-                          <a14:hiddenEffects xmlns:a14="http://schemas.microsoft.com/office/drawing/2010/main">
-                            <a:effectLst>
-                              <a:outerShdw dist="35921" dir="2700000" algn="ctr" rotWithShape="0">
-                                <a:srgbClr val="808080"/>
-                              </a:outerShdw>
-                            </a:effectLst>
-                          </a14:hiddenEffects>
-                        </a:ext>
-                      </a:extLst>
-                    </p:spPr>
-                  </p:pic>
-                </p:oleObj>
-              </mc:Fallback>
-            </mc:AlternateContent>
-          </a:graphicData>
-        </a:graphic>
-      </p:graphicFrame>
       <p:sp>
         <p:nvSpPr>
           <p:cNvPr id="2" name="Rectangle 1"/>
@@ -16220,6 +15655,37 @@
             <a:r>
               <a:rPr lang="en-US" dirty="0"/>
               <a:t> of a Poisson random variable</a:t>
+            </a:r>
+          </a:p>
+        </p:txBody>
+      </p:sp>
+      <p:sp>
+        <p:nvSpPr>
+          <p:cNvPr id="9220" name="TextBox 9219"/>
+          <p:cNvSpPr txBox="1"/>
+          <p:nvPr/>
+        </p:nvSpPr>
+        <p:spPr>
+          <a:xfrm>
+            <a:off x="4564063" y="4183064"/>
+            <a:ext cx="2590800" cy="700087"/>
+          </a:xfrm>
+          <a:prstGeom prst="rect">
+            <a:avLst/>
+          </a:prstGeom>
+          <a:noFill/>
+        </p:spPr>
+        <p:txBody>
+          <a:bodyPr wrap="square" anchor="ctr" lIns="0" rIns="0" tIns="0" bIns="0">
+            <a:spAutoFit/>
+          </a:bodyPr>
+          <a:lstStyle/>
+          <a:p>
+            <a:r>
+              <a:rPr sz="2600">
+                <a:latin typeface="Cambria"/>
+              </a:rPr>
+              <a:t>X ≈ N(μ, √μ)</a:t>
             </a:r>
           </a:p>
         </p:txBody>
@@ -17267,101 +16733,6 @@
           </a:extLst>
         </p:spPr>
       </p:pic>
-      <p:graphicFrame>
-        <p:nvGraphicFramePr>
-          <p:cNvPr id="7172" name="Object 6"/>
-          <p:cNvGraphicFramePr>
-            <a:graphicFrameLocks noGrp="1" noChangeAspect="1"/>
-          </p:cNvGraphicFramePr>
-          <p:nvPr>
-            <p:ph sz="half" idx="2"/>
-          </p:nvPr>
-        </p:nvGraphicFramePr>
-        <p:xfrm>
-          <a:off x="2362200" y="2286001"/>
-          <a:ext cx="2306638" cy="1552575"/>
-        </p:xfrm>
-        <a:graphic>
-          <a:graphicData uri="http://schemas.openxmlformats.org/presentationml/2006/ole">
-            <mc:AlternateContent xmlns:mc="http://schemas.openxmlformats.org/markup-compatibility/2006">
-              <mc:Choice xmlns:v="urn:schemas-microsoft-com:vml" Requires="v">
-                <p:oleObj name="Equation" r:id="rId4" imgW="622030" imgH="418918" progId="Equation.DSMT4">
-                  <p:embed/>
-                </p:oleObj>
-              </mc:Choice>
-              <mc:Fallback>
-                <p:oleObj name="Equation" r:id="rId4" imgW="622030" imgH="418918" progId="Equation.DSMT4">
-                  <p:embed/>
-                  <p:pic>
-                    <p:nvPicPr>
-                      <p:cNvPr id="0" name=""/>
-                      <p:cNvPicPr>
-                        <a:picLocks noChangeAspect="1" noChangeArrowheads="1"/>
-                      </p:cNvPicPr>
-                      <p:nvPr/>
-                    </p:nvPicPr>
-                    <p:blipFill>
-                      <a:blip r:embed="rId5">
-                        <a:extLst>
-                          <a:ext uri="{28A0092B-C50C-407E-A947-70E740481C1C}">
-                            <a14:useLocalDpi xmlns:a14="http://schemas.microsoft.com/office/drawing/2010/main" val="0"/>
-                          </a:ext>
-                        </a:extLst>
-                      </a:blip>
-                      <a:srcRect/>
-                      <a:stretch>
-                        <a:fillRect/>
-                      </a:stretch>
-                    </p:blipFill>
-                    <p:spPr bwMode="auto">
-                      <a:xfrm>
-                        <a:off x="2362200" y="2286001"/>
-                        <a:ext cx="2306638" cy="1552575"/>
-                      </a:xfrm>
-                      <a:prstGeom prst="rect">
-                        <a:avLst/>
-                      </a:prstGeom>
-                      <a:noFill/>
-                      <a:ln>
-                        <a:noFill/>
-                      </a:ln>
-                      <a:effectLst/>
-                      <a:extLst>
-                        <a:ext uri="{909E8E84-426E-40DD-AFC4-6F175D3DCCD1}">
-                          <a14:hiddenFill xmlns:a14="http://schemas.microsoft.com/office/drawing/2010/main">
-                            <a:solidFill>
-                              <a:srgbClr val="FFFFFF"/>
-                            </a:solidFill>
-                          </a14:hiddenFill>
-                        </a:ext>
-                        <a:ext uri="{91240B29-F687-4F45-9708-019B960494DF}">
-                          <a14:hiddenLine xmlns:a14="http://schemas.microsoft.com/office/drawing/2010/main" w="9525">
-                            <a:solidFill>
-                              <a:srgbClr val="000000"/>
-                            </a:solidFill>
-                            <a:miter lim="800000"/>
-                            <a:headEnd/>
-                            <a:tailEnd/>
-                          </a14:hiddenLine>
-                        </a:ext>
-                        <a:ext uri="{AF507438-7753-43E0-B8FC-AC1667EBCBE1}">
-                          <a14:hiddenEffects xmlns:a14="http://schemas.microsoft.com/office/drawing/2010/main">
-                            <a:effectLst>
-                              <a:outerShdw dist="35921" dir="2700000" algn="ctr" rotWithShape="0">
-                                <a:srgbClr val="808080"/>
-                              </a:outerShdw>
-                            </a:effectLst>
-                          </a14:hiddenEffects>
-                        </a:ext>
-                      </a:extLst>
-                    </p:spPr>
-                  </p:pic>
-                </p:oleObj>
-              </mc:Fallback>
-            </mc:AlternateContent>
-          </a:graphicData>
-        </a:graphic>
-      </p:graphicFrame>
       <p:sp>
         <p:nvSpPr>
           <p:cNvPr id="7173" name="Text Box 8"/>
@@ -17829,6 +17200,37 @@
           </a:p>
         </p:txBody>
       </p:sp>
+      <p:sp>
+        <p:nvSpPr>
+          <p:cNvPr id="7177" name="TextBox 7176"/>
+          <p:cNvSpPr txBox="1"/>
+          <p:nvPr/>
+        </p:nvSpPr>
+        <p:spPr>
+          <a:xfrm>
+            <a:off x="2362200" y="2286001"/>
+            <a:ext cx="2306638" cy="1552575"/>
+          </a:xfrm>
+          <a:prstGeom prst="rect">
+            <a:avLst/>
+          </a:prstGeom>
+          <a:noFill/>
+        </p:spPr>
+        <p:txBody>
+          <a:bodyPr wrap="square" anchor="ctr" lIns="0" rIns="0" tIns="0" bIns="0">
+            <a:spAutoFit/>
+          </a:bodyPr>
+          <a:lstStyle/>
+          <a:p>
+            <a:r>
+              <a:rPr sz="1400">
+                <a:latin typeface="Cambria"/>
+              </a:rPr>
+              <a:t>t = (x̄ − μ) / (s / √n)</a:t>
+            </a:r>
+          </a:p>
+        </p:txBody>
+      </p:sp>
     </p:spTree>
     <p:extLst>
       <p:ext uri="{BB962C8B-B14F-4D97-AF65-F5344CB8AC3E}">
@@ -17956,10 +17358,8 @@
               <a:t>(</a:t>
             </a:r>
             <a:r>
-              <a:rPr lang="en-US" altLang="en-US" sz="2400" i="1" dirty="0">
-                <a:sym typeface="Symbol" charset="2"/>
-              </a:rPr>
-              <a:t>,</a:t>
+              <a:rPr lang="en-US" altLang="en-US" sz="2400" i="1" dirty="0"/>
+              <a:t>μ,</a:t>
             </a:r>
             <a:r>
               <a:rPr lang="el-GR" sz="2400" dirty="0"/>
@@ -17986,10 +17386,8 @@
               <a:t> ~ lognormal(</a:t>
             </a:r>
             <a:r>
-              <a:rPr lang="en-US" altLang="en-US" sz="2400" i="1" dirty="0">
-                <a:sym typeface="Symbol" charset="2"/>
-              </a:rPr>
-              <a:t>,</a:t>
+              <a:rPr lang="en-US" altLang="en-US" sz="2400" i="1" dirty="0"/>
+              <a:t>μ,</a:t>
             </a:r>
             <a:r>
               <a:rPr lang="el-GR" sz="2400" dirty="0"/>
@@ -19586,10 +18984,8 @@
               <a:t>If events are occurring at random with average rate of </a:t>
             </a:r>
             <a:r>
-              <a:rPr lang="en-US" altLang="en-US" sz="2600" dirty="0">
-                <a:sym typeface="Symbol" charset="2"/>
-              </a:rPr>
-              <a:t> per interval, then the </a:t>
+              <a:rPr lang="en-US" altLang="en-US" sz="2600" dirty="0"/>
+              <a:t>λ per interval, then the </a:t>
             </a:r>
             <a:r>
               <a:rPr lang="en-US" altLang="en-US" sz="2600" b="1" dirty="0">
@@ -19606,106 +19002,6 @@
           </a:p>
         </p:txBody>
       </p:sp>
-      <p:graphicFrame>
-        <p:nvGraphicFramePr>
-          <p:cNvPr id="277507" name="Object 4"/>
-          <p:cNvGraphicFramePr>
-            <a:graphicFrameLocks noGrp="1" noChangeAspect="1"/>
-          </p:cNvGraphicFramePr>
-          <p:nvPr>
-            <p:ph sz="half" idx="2"/>
-            <p:extLst>
-              <p:ext uri="{D42A27DB-BD31-4B8C-83A1-F6EECF244321}">
-                <p14:modId xmlns:p14="http://schemas.microsoft.com/office/powerpoint/2010/main" val="1203704957"/>
-              </p:ext>
-            </p:extLst>
-          </p:nvPr>
-        </p:nvGraphicFramePr>
-        <p:xfrm>
-          <a:off x="4904630" y="4794907"/>
-          <a:ext cx="2209800" cy="622300"/>
-        </p:xfrm>
-        <a:graphic>
-          <a:graphicData uri="http://schemas.openxmlformats.org/presentationml/2006/ole">
-            <mc:AlternateContent xmlns:mc="http://schemas.openxmlformats.org/markup-compatibility/2006">
-              <mc:Choice xmlns:v="urn:schemas-microsoft-com:vml" Requires="v">
-                <p:oleObj name="Equation" r:id="rId3" imgW="812447" imgH="228501" progId="Equation.DSMT4">
-                  <p:embed/>
-                </p:oleObj>
-              </mc:Choice>
-              <mc:Fallback>
-                <p:oleObj name="Equation" r:id="rId3" imgW="812447" imgH="228501" progId="Equation.DSMT4">
-                  <p:embed/>
-                  <p:pic>
-                    <p:nvPicPr>
-                      <p:cNvPr id="0" name=""/>
-                      <p:cNvPicPr>
-                        <a:picLocks noChangeAspect="1" noChangeArrowheads="1"/>
-                      </p:cNvPicPr>
-                      <p:nvPr/>
-                    </p:nvPicPr>
-                    <p:blipFill>
-                      <a:blip r:embed="rId4">
-                        <a:extLst>
-                          <a:ext uri="{28A0092B-C50C-407E-A947-70E740481C1C}">
-                            <a14:useLocalDpi xmlns:a14="http://schemas.microsoft.com/office/drawing/2010/main" val="0"/>
-                          </a:ext>
-                        </a:extLst>
-                      </a:blip>
-                      <a:srcRect/>
-                      <a:stretch>
-                        <a:fillRect/>
-                      </a:stretch>
-                    </p:blipFill>
-                    <p:spPr bwMode="auto">
-                      <a:xfrm>
-                        <a:off x="4904630" y="4794907"/>
-                        <a:ext cx="2209800" cy="622300"/>
-                      </a:xfrm>
-                      <a:prstGeom prst="rect">
-                        <a:avLst/>
-                      </a:prstGeom>
-                      <a:noFill/>
-                      <a:ln>
-                        <a:noFill/>
-                      </a:ln>
-                      <a:effectLst/>
-                      <a:extLst>
-                        <a:ext uri="{909E8E84-426E-40DD-AFC4-6F175D3DCCD1}">
-                          <a14:hiddenFill xmlns:a14="http://schemas.microsoft.com/office/drawing/2010/main">
-                            <a:solidFill>
-                              <a:srgbClr val="FFFFFF"/>
-                            </a:solidFill>
-                          </a14:hiddenFill>
-                        </a:ext>
-                        <a:ext uri="{91240B29-F687-4F45-9708-019B960494DF}">
-                          <a14:hiddenLine xmlns:a14="http://schemas.microsoft.com/office/drawing/2010/main" w="9525">
-                            <a:solidFill>
-                              <a:srgbClr val="000000"/>
-                            </a:solidFill>
-                            <a:miter lim="800000"/>
-                            <a:headEnd/>
-                            <a:tailEnd/>
-                          </a14:hiddenLine>
-                        </a:ext>
-                        <a:ext uri="{AF507438-7753-43E0-B8FC-AC1667EBCBE1}">
-                          <a14:hiddenEffects xmlns:a14="http://schemas.microsoft.com/office/drawing/2010/main">
-                            <a:effectLst>
-                              <a:outerShdw dist="35921" dir="2700000" algn="ctr" rotWithShape="0">
-                                <a:srgbClr val="808080"/>
-                              </a:outerShdw>
-                            </a:effectLst>
-                          </a14:hiddenEffects>
-                        </a:ext>
-                      </a:extLst>
-                    </p:spPr>
-                  </p:pic>
-                </p:oleObj>
-              </mc:Fallback>
-            </mc:AlternateContent>
-          </a:graphicData>
-        </a:graphic>
-      </p:graphicFrame>
       <p:sp>
         <p:nvSpPr>
           <p:cNvPr id="2" name="TextBox 1"/>
@@ -19844,6 +19140,43 @@
           </p:sp>
         </mc:Fallback>
       </mc:AlternateContent>
+      <p:sp>
+        <p:nvSpPr>
+          <p:cNvPr id="12292" name="TextBox 12291"/>
+          <p:cNvSpPr txBox="1"/>
+          <p:nvPr/>
+        </p:nvSpPr>
+        <p:spPr>
+          <a:xfrm>
+            <a:off x="4904630" y="4794907"/>
+            <a:ext cx="2209800" cy="622300"/>
+          </a:xfrm>
+          <a:prstGeom prst="rect">
+            <a:avLst/>
+          </a:prstGeom>
+          <a:noFill/>
+        </p:spPr>
+        <p:txBody>
+          <a:bodyPr wrap="square" anchor="ctr" lIns="0" rIns="0" tIns="0" bIns="0">
+            <a:spAutoFit/>
+          </a:bodyPr>
+          <a:lstStyle/>
+          <a:p>
+            <a:r>
+              <a:rPr sz="2400">
+                <a:latin typeface="Cambria"/>
+              </a:rPr>
+              <a:t>f(x) = λ e</a:t>
+            </a:r>
+            <a:r>
+              <a:rPr sz="2400" baseline="30000">
+                <a:latin typeface="Cambria"/>
+              </a:rPr>
+              <a:t>−λx</a:t>
+            </a:r>
+          </a:p>
+        </p:txBody>
+      </p:sp>
     </p:spTree>
     <p:extLst>
       <p:ext uri="{BB962C8B-B14F-4D97-AF65-F5344CB8AC3E}">
@@ -21150,7 +20483,7 @@
       </p:sp>
       <p:graphicFrame>
         <p:nvGraphicFramePr>
-          <p:cNvPr id="279555" name="Object 4"/>
+          <p:cNvPr id="279555" name="Object 4" descr="Line plot of the exponential distribution used for time between spawnings. The x-axis is time between spawnings in weeks, 0 to 5; the y-axis is density, 0 to 0.08. A smooth exponential decay curve starts at about 0.075 at time 0, falls steeply to roughly 0.02 by 2 weeks, and flattens toward 0 beyond about 4 weeks, showing that short intervals between spawnings are most likely and long intervals become increasingly rare."/>
           <p:cNvGraphicFramePr>
             <a:graphicFrameLocks noGrp="1" noChangeAspect="1"/>
           </p:cNvGraphicFramePr>
@@ -21853,206 +21186,6 @@
           </a:p>
         </p:txBody>
       </p:sp>
-      <p:graphicFrame>
-        <p:nvGraphicFramePr>
-          <p:cNvPr id="285699" name="Object 4"/>
-          <p:cNvGraphicFramePr>
-            <a:graphicFrameLocks noGrp="1" noChangeAspect="1"/>
-          </p:cNvGraphicFramePr>
-          <p:nvPr>
-            <p:ph sz="quarter" idx="2"/>
-            <p:extLst>
-              <p:ext uri="{D42A27DB-BD31-4B8C-83A1-F6EECF244321}">
-                <p14:modId xmlns:p14="http://schemas.microsoft.com/office/powerpoint/2010/main" val="1533184933"/>
-              </p:ext>
-            </p:extLst>
-          </p:nvPr>
-        </p:nvGraphicFramePr>
-        <p:xfrm>
-          <a:off x="5181601" y="2761264"/>
-          <a:ext cx="1571625" cy="412750"/>
-        </p:xfrm>
-        <a:graphic>
-          <a:graphicData uri="http://schemas.openxmlformats.org/presentationml/2006/ole">
-            <mc:AlternateContent xmlns:mc="http://schemas.openxmlformats.org/markup-compatibility/2006">
-              <mc:Choice xmlns:v="urn:schemas-microsoft-com:vml" Requires="v">
-                <p:oleObj name="Equation" r:id="rId3" imgW="774364" imgH="203112" progId="Equation.DSMT4">
-                  <p:embed/>
-                </p:oleObj>
-              </mc:Choice>
-              <mc:Fallback>
-                <p:oleObj name="Equation" r:id="rId3" imgW="774364" imgH="203112" progId="Equation.DSMT4">
-                  <p:embed/>
-                  <p:pic>
-                    <p:nvPicPr>
-                      <p:cNvPr id="0" name=""/>
-                      <p:cNvPicPr>
-                        <a:picLocks noChangeAspect="1" noChangeArrowheads="1"/>
-                      </p:cNvPicPr>
-                      <p:nvPr/>
-                    </p:nvPicPr>
-                    <p:blipFill>
-                      <a:blip r:embed="rId4">
-                        <a:extLst>
-                          <a:ext uri="{28A0092B-C50C-407E-A947-70E740481C1C}">
-                            <a14:useLocalDpi xmlns:a14="http://schemas.microsoft.com/office/drawing/2010/main" val="0"/>
-                          </a:ext>
-                        </a:extLst>
-                      </a:blip>
-                      <a:srcRect/>
-                      <a:stretch>
-                        <a:fillRect/>
-                      </a:stretch>
-                    </p:blipFill>
-                    <p:spPr bwMode="auto">
-                      <a:xfrm>
-                        <a:off x="5181601" y="2761264"/>
-                        <a:ext cx="1571625" cy="412750"/>
-                      </a:xfrm>
-                      <a:prstGeom prst="rect">
-                        <a:avLst/>
-                      </a:prstGeom>
-                      <a:noFill/>
-                      <a:ln>
-                        <a:noFill/>
-                      </a:ln>
-                      <a:effectLst/>
-                      <a:extLst>
-                        <a:ext uri="{909E8E84-426E-40DD-AFC4-6F175D3DCCD1}">
-                          <a14:hiddenFill xmlns:a14="http://schemas.microsoft.com/office/drawing/2010/main">
-                            <a:solidFill>
-                              <a:srgbClr val="FFFFFF"/>
-                            </a:solidFill>
-                          </a14:hiddenFill>
-                        </a:ext>
-                        <a:ext uri="{91240B29-F687-4F45-9708-019B960494DF}">
-                          <a14:hiddenLine xmlns:a14="http://schemas.microsoft.com/office/drawing/2010/main" w="9525">
-                            <a:solidFill>
-                              <a:srgbClr val="000000"/>
-                            </a:solidFill>
-                            <a:miter lim="800000"/>
-                            <a:headEnd/>
-                            <a:tailEnd/>
-                          </a14:hiddenLine>
-                        </a:ext>
-                        <a:ext uri="{AF507438-7753-43E0-B8FC-AC1667EBCBE1}">
-                          <a14:hiddenEffects xmlns:a14="http://schemas.microsoft.com/office/drawing/2010/main">
-                            <a:effectLst>
-                              <a:outerShdw dist="35921" dir="2700000" algn="ctr" rotWithShape="0">
-                                <a:srgbClr val="808080"/>
-                              </a:outerShdw>
-                            </a:effectLst>
-                          </a14:hiddenEffects>
-                        </a:ext>
-                      </a:extLst>
-                    </p:spPr>
-                  </p:pic>
-                </p:oleObj>
-              </mc:Fallback>
-            </mc:AlternateContent>
-          </a:graphicData>
-        </a:graphic>
-      </p:graphicFrame>
-      <p:graphicFrame>
-        <p:nvGraphicFramePr>
-          <p:cNvPr id="285700" name="Object 6"/>
-          <p:cNvGraphicFramePr>
-            <a:graphicFrameLocks noGrp="1" noChangeAspect="1"/>
-          </p:cNvGraphicFramePr>
-          <p:nvPr>
-            <p:ph sz="quarter" idx="3"/>
-            <p:extLst>
-              <p:ext uri="{D42A27DB-BD31-4B8C-83A1-F6EECF244321}">
-                <p14:modId xmlns:p14="http://schemas.microsoft.com/office/powerpoint/2010/main" val="841090861"/>
-              </p:ext>
-            </p:extLst>
-          </p:nvPr>
-        </p:nvGraphicFramePr>
-        <p:xfrm>
-          <a:off x="5155069" y="4324092"/>
-          <a:ext cx="1600200" cy="787400"/>
-        </p:xfrm>
-        <a:graphic>
-          <a:graphicData uri="http://schemas.openxmlformats.org/presentationml/2006/ole">
-            <mc:AlternateContent xmlns:mc="http://schemas.openxmlformats.org/markup-compatibility/2006">
-              <mc:Choice xmlns:v="urn:schemas-microsoft-com:vml" Requires="v">
-                <p:oleObj name="Equation" r:id="rId5" imgW="799753" imgH="393529" progId="Equation.DSMT4">
-                  <p:embed/>
-                </p:oleObj>
-              </mc:Choice>
-              <mc:Fallback>
-                <p:oleObj name="Equation" r:id="rId5" imgW="799753" imgH="393529" progId="Equation.DSMT4">
-                  <p:embed/>
-                  <p:pic>
-                    <p:nvPicPr>
-                      <p:cNvPr id="0" name=""/>
-                      <p:cNvPicPr>
-                        <a:picLocks noChangeAspect="1" noChangeArrowheads="1"/>
-                      </p:cNvPicPr>
-                      <p:nvPr/>
-                    </p:nvPicPr>
-                    <p:blipFill>
-                      <a:blip r:embed="rId6">
-                        <a:extLst>
-                          <a:ext uri="{28A0092B-C50C-407E-A947-70E740481C1C}">
-                            <a14:useLocalDpi xmlns:a14="http://schemas.microsoft.com/office/drawing/2010/main" val="0"/>
-                          </a:ext>
-                        </a:extLst>
-                      </a:blip>
-                      <a:srcRect/>
-                      <a:stretch>
-                        <a:fillRect/>
-                      </a:stretch>
-                    </p:blipFill>
-                    <p:spPr bwMode="auto">
-                      <a:xfrm>
-                        <a:off x="5155069" y="4324092"/>
-                        <a:ext cx="1600200" cy="787400"/>
-                      </a:xfrm>
-                      <a:prstGeom prst="rect">
-                        <a:avLst/>
-                      </a:prstGeom>
-                      <a:noFill/>
-                      <a:ln>
-                        <a:noFill/>
-                      </a:ln>
-                      <a:effectLst/>
-                      <a:extLst>
-                        <a:ext uri="{909E8E84-426E-40DD-AFC4-6F175D3DCCD1}">
-                          <a14:hiddenFill xmlns:a14="http://schemas.microsoft.com/office/drawing/2010/main">
-                            <a:solidFill>
-                              <a:srgbClr val="FFFFFF"/>
-                            </a:solidFill>
-                          </a14:hiddenFill>
-                        </a:ext>
-                        <a:ext uri="{91240B29-F687-4F45-9708-019B960494DF}">
-                          <a14:hiddenLine xmlns:a14="http://schemas.microsoft.com/office/drawing/2010/main" w="9525">
-                            <a:solidFill>
-                              <a:srgbClr val="000000"/>
-                            </a:solidFill>
-                            <a:miter lim="800000"/>
-                            <a:headEnd/>
-                            <a:tailEnd/>
-                          </a14:hiddenLine>
-                        </a:ext>
-                        <a:ext uri="{AF507438-7753-43E0-B8FC-AC1667EBCBE1}">
-                          <a14:hiddenEffects xmlns:a14="http://schemas.microsoft.com/office/drawing/2010/main">
-                            <a:effectLst>
-                              <a:outerShdw dist="35921" dir="2700000" algn="ctr" rotWithShape="0">
-                                <a:srgbClr val="808080"/>
-                              </a:outerShdw>
-                            </a:effectLst>
-                          </a14:hiddenEffects>
-                        </a:ext>
-                      </a:extLst>
-                    </p:spPr>
-                  </p:pic>
-                </p:oleObj>
-              </mc:Fallback>
-            </mc:AlternateContent>
-          </a:graphicData>
-        </a:graphic>
-      </p:graphicFrame>
       <p:sp>
         <p:nvSpPr>
           <p:cNvPr id="2" name="TextBox 1"/>
@@ -22117,6 +21250,68 @@
                 </a:solidFill>
               </a:rPr>
               <a:t>Group Work</a:t>
+            </a:r>
+          </a:p>
+        </p:txBody>
+      </p:sp>
+      <p:sp>
+        <p:nvSpPr>
+          <p:cNvPr id="285701" name="TextBox 285700"/>
+          <p:cNvSpPr txBox="1"/>
+          <p:nvPr/>
+        </p:nvSpPr>
+        <p:spPr>
+          <a:xfrm>
+            <a:off x="5181601" y="2761264"/>
+            <a:ext cx="1571625" cy="412750"/>
+          </a:xfrm>
+          <a:prstGeom prst="rect">
+            <a:avLst/>
+          </a:prstGeom>
+          <a:noFill/>
+        </p:spPr>
+        <p:txBody>
+          <a:bodyPr wrap="square" anchor="ctr" lIns="0" rIns="0" tIns="0" bIns="0">
+            <a:spAutoFit/>
+          </a:bodyPr>
+          <a:lstStyle/>
+          <a:p>
+            <a:r>
+              <a:rPr sz="2000">
+                <a:latin typeface="Cambria"/>
+              </a:rPr>
+              <a:t>Z ~ U(a, b)</a:t>
+            </a:r>
+          </a:p>
+        </p:txBody>
+      </p:sp>
+      <p:sp>
+        <p:nvSpPr>
+          <p:cNvPr id="285702" name="TextBox 285701"/>
+          <p:cNvSpPr txBox="1"/>
+          <p:nvPr/>
+        </p:nvSpPr>
+        <p:spPr>
+          <a:xfrm>
+            <a:off x="5155069" y="4324092"/>
+            <a:ext cx="2532184" cy="787400"/>
+          </a:xfrm>
+          <a:prstGeom prst="rect">
+            <a:avLst/>
+          </a:prstGeom>
+          <a:noFill/>
+        </p:spPr>
+        <p:txBody>
+          <a:bodyPr wrap="square" anchor="ctr" lIns="0" rIns="0" tIns="0" bIns="0">
+            <a:spAutoFit/>
+          </a:bodyPr>
+          <a:lstStyle/>
+          <a:p>
+            <a:r>
+              <a:rPr sz="1900">
+                <a:latin typeface="Cambria"/>
+              </a:rPr>
+              <a:t>f(x) = 1 / (b − a)</a:t>
             </a:r>
           </a:p>
         </p:txBody>
@@ -22259,111 +21454,6 @@
           </a:p>
         </p:txBody>
       </p:sp>
-      <p:graphicFrame>
-        <p:nvGraphicFramePr>
-          <p:cNvPr id="5" name="Object 6">
-            <a:extLst>
-              <a:ext uri="{FF2B5EF4-FFF2-40B4-BE49-F238E27FC236}">
-                <a16:creationId xmlns:a16="http://schemas.microsoft.com/office/drawing/2014/main" id="{B06D115A-8E44-E087-E6DD-61D636020508}"/>
-              </a:ext>
-            </a:extLst>
-          </p:cNvPr>
-          <p:cNvGraphicFramePr>
-            <a:graphicFrameLocks noChangeAspect="1"/>
-          </p:cNvGraphicFramePr>
-          <p:nvPr>
-            <p:extLst>
-              <p:ext uri="{D42A27DB-BD31-4B8C-83A1-F6EECF244321}">
-                <p14:modId xmlns:p14="http://schemas.microsoft.com/office/powerpoint/2010/main" val="4063655564"/>
-              </p:ext>
-            </p:extLst>
-          </p:nvPr>
-        </p:nvGraphicFramePr>
-        <p:xfrm>
-          <a:off x="5494401" y="1275443"/>
-          <a:ext cx="1600200" cy="787400"/>
-        </p:xfrm>
-        <a:graphic>
-          <a:graphicData uri="http://schemas.openxmlformats.org/presentationml/2006/ole">
-            <mc:AlternateContent xmlns:mc="http://schemas.openxmlformats.org/markup-compatibility/2006">
-              <mc:Choice xmlns:v="urn:schemas-microsoft-com:vml" Requires="v">
-                <p:oleObj name="Equation" r:id="rId3" imgW="799753" imgH="393529" progId="Equation.DSMT4">
-                  <p:embed/>
-                </p:oleObj>
-              </mc:Choice>
-              <mc:Fallback>
-                <p:oleObj name="Equation" r:id="rId3" imgW="799753" imgH="393529" progId="Equation.DSMT4">
-                  <p:embed/>
-                  <p:pic>
-                    <p:nvPicPr>
-                      <p:cNvPr id="285700" name="Object 6"/>
-                      <p:cNvPicPr>
-                        <a:picLocks noChangeAspect="1" noChangeArrowheads="1"/>
-                      </p:cNvPicPr>
-                      <p:nvPr/>
-                    </p:nvPicPr>
-                    <p:blipFill>
-                      <a:blip r:embed="rId4">
-                        <a:extLst>
-                          <a:ext uri="{28A0092B-C50C-407E-A947-70E740481C1C}">
-                            <a14:useLocalDpi xmlns:a14="http://schemas.microsoft.com/office/drawing/2010/main" val="0"/>
-                          </a:ext>
-                        </a:extLst>
-                      </a:blip>
-                      <a:srcRect/>
-                      <a:stretch>
-                        <a:fillRect/>
-                      </a:stretch>
-                    </p:blipFill>
-                    <p:spPr bwMode="auto">
-                      <a:xfrm>
-                        <a:off x="5494401" y="1275443"/>
-                        <a:ext cx="1600200" cy="787400"/>
-                      </a:xfrm>
-                      <a:prstGeom prst="rect">
-                        <a:avLst/>
-                      </a:prstGeom>
-                      <a:noFill/>
-                      <a:ln>
-                        <a:noFill/>
-                      </a:ln>
-                      <a:effectLst/>
-                      <a:extLst>
-                        <a:ext uri="{909E8E84-426E-40DD-AFC4-6F175D3DCCD1}">
-                          <a14:hiddenFill xmlns:a14="http://schemas.microsoft.com/office/drawing/2010/main">
-                            <a:solidFill>
-                              <a:srgbClr val="FFFFFF"/>
-                            </a:solidFill>
-                          </a14:hiddenFill>
-                        </a:ext>
-                        <a:ext uri="{91240B29-F687-4F45-9708-019B960494DF}">
-                          <a14:hiddenLine xmlns:a14="http://schemas.microsoft.com/office/drawing/2010/main" w="9525">
-                            <a:solidFill>
-                              <a:srgbClr val="000000"/>
-                            </a:solidFill>
-                            <a:miter lim="800000"/>
-                            <a:headEnd/>
-                            <a:tailEnd/>
-                          </a14:hiddenLine>
-                        </a:ext>
-                        <a:ext uri="{AF507438-7753-43E0-B8FC-AC1667EBCBE1}">
-                          <a14:hiddenEffects xmlns:a14="http://schemas.microsoft.com/office/drawing/2010/main">
-                            <a:effectLst>
-                              <a:outerShdw dist="35921" dir="2700000" algn="ctr" rotWithShape="0">
-                                <a:srgbClr val="808080"/>
-                              </a:outerShdw>
-                            </a:effectLst>
-                          </a14:hiddenEffects>
-                        </a:ext>
-                      </a:extLst>
-                    </p:spPr>
-                  </p:pic>
-                </p:oleObj>
-              </mc:Fallback>
-            </mc:AlternateContent>
-          </a:graphicData>
-        </a:graphic>
-      </p:graphicFrame>
       <p:sp>
         <p:nvSpPr>
           <p:cNvPr id="6" name="TextBox 5">
@@ -22465,6 +21555,37 @@
             <a:r>
               <a:rPr lang="en-US" sz="4400" dirty="0"/>
               <a:t>2</a:t>
+            </a:r>
+          </a:p>
+        </p:txBody>
+      </p:sp>
+      <p:sp>
+        <p:nvSpPr>
+          <p:cNvPr id="16388" name="TextBox 16387"/>
+          <p:cNvSpPr txBox="1"/>
+          <p:nvPr/>
+        </p:nvSpPr>
+        <p:spPr>
+          <a:xfrm>
+            <a:off x="5494401" y="1275443"/>
+            <a:ext cx="2532184" cy="787400"/>
+          </a:xfrm>
+          <a:prstGeom prst="rect">
+            <a:avLst/>
+          </a:prstGeom>
+          <a:noFill/>
+        </p:spPr>
+        <p:txBody>
+          <a:bodyPr wrap="square" anchor="ctr" lIns="0" rIns="0" tIns="0" bIns="0">
+            <a:spAutoFit/>
+          </a:bodyPr>
+          <a:lstStyle/>
+          <a:p>
+            <a:r>
+              <a:rPr sz="1900">
+                <a:latin typeface="Cambria"/>
+              </a:rPr>
+              <a:t>f(x) = 1 / (b − a)</a:t>
             </a:r>
           </a:p>
         </p:txBody>
@@ -25233,10 +24354,8 @@
               <a:defRPr/>
             </a:pPr>
             <a:r>
-              <a:rPr lang="en-US" altLang="en-US" sz="1400">
-                <a:sym typeface="Symbol" charset="2"/>
-              </a:rPr>
-              <a:t></a:t>
+              <a:rPr lang="en-US" altLang="en-US" sz="1400"/>
+              <a:t>μ</a:t>
             </a:r>
           </a:p>
         </p:txBody>
@@ -25400,10 +24519,8 @@
               <a:defRPr/>
             </a:pPr>
             <a:r>
-              <a:rPr lang="en-US" altLang="en-US" sz="1400">
-                <a:sym typeface="Symbol" charset="2"/>
-              </a:rPr>
-              <a:t>-</a:t>
+              <a:rPr lang="en-US" altLang="en-US" sz="1400"/>
+              <a:t>μ-σ</a:t>
             </a:r>
           </a:p>
         </p:txBody>
@@ -25567,10 +24684,8 @@
               <a:defRPr/>
             </a:pPr>
             <a:r>
-              <a:rPr lang="en-US" altLang="en-US" sz="1400">
-                <a:sym typeface="Symbol" charset="2"/>
-              </a:rPr>
-              <a:t>-2</a:t>
+              <a:rPr lang="en-US" altLang="en-US" sz="1400"/>
+              <a:t>μ-2σ</a:t>
             </a:r>
           </a:p>
         </p:txBody>
@@ -25734,10 +24849,8 @@
               <a:defRPr/>
             </a:pPr>
             <a:r>
-              <a:rPr lang="en-US" altLang="en-US" sz="1400">
-                <a:sym typeface="Symbol" charset="2"/>
-              </a:rPr>
-              <a:t>-3</a:t>
+              <a:rPr lang="en-US" altLang="en-US" sz="1400"/>
+              <a:t>μ-3σ</a:t>
             </a:r>
           </a:p>
         </p:txBody>
@@ -25901,10 +25014,8 @@
               <a:defRPr/>
             </a:pPr>
             <a:r>
-              <a:rPr lang="en-US" altLang="en-US" sz="1400">
-                <a:sym typeface="Symbol" charset="2"/>
-              </a:rPr>
-              <a:t>+3</a:t>
+              <a:rPr lang="en-US" altLang="en-US" sz="1400"/>
+              <a:t>μ+3σ</a:t>
             </a:r>
           </a:p>
         </p:txBody>
@@ -26068,10 +25179,8 @@
               <a:defRPr/>
             </a:pPr>
             <a:r>
-              <a:rPr lang="en-US" altLang="en-US" sz="1400">
-                <a:sym typeface="Symbol" charset="2"/>
-              </a:rPr>
-              <a:t>+2</a:t>
+              <a:rPr lang="en-US" altLang="en-US" sz="1400"/>
+              <a:t>μ+2σ</a:t>
             </a:r>
           </a:p>
         </p:txBody>
@@ -26235,10 +25344,8 @@
               <a:defRPr/>
             </a:pPr>
             <a:r>
-              <a:rPr lang="en-US" altLang="en-US" sz="1400">
-                <a:sym typeface="Symbol" charset="2"/>
-              </a:rPr>
-              <a:t>+</a:t>
+              <a:rPr lang="en-US" altLang="en-US" sz="1400"/>
+              <a:t>μ+σ</a:t>
             </a:r>
           </a:p>
         </p:txBody>

</xml_diff>